<commit_message>
Fix Asset Nova round 2 slide 8 overflow
Co-Authored-By: Alexandre Cela <alexandrecelap@gmail.com>
</commit_message>
<xml_diff>
--- a/outputs/prototypes/asset-nova-round2-deck.pptx
+++ b/outputs/prototypes/asset-nova-round2-deck.pptx
@@ -3150,7 +3150,7 @@
       <p:grpSpPr/>
       <p:pic>
         <p:nvPicPr>
-          <p:cNvPr id="2" name="Picture 1" descr="slide-06.png"/>
+          <p:cNvPr id="2" name="Picture 1" descr="slide-07.png"/>
           <p:cNvPicPr>
             <a:picLocks noChangeAspect="1"/>
           </p:cNvPicPr>
@@ -3192,7 +3192,7 @@
       <p:grpSpPr/>
       <p:pic>
         <p:nvPicPr>
-          <p:cNvPr id="2" name="Picture 1" descr="slide-06.png"/>
+          <p:cNvPr id="2" name="Picture 1" descr="slide-07.png"/>
           <p:cNvPicPr>
             <a:picLocks noChangeAspect="1"/>
           </p:cNvPicPr>
@@ -3234,7 +3234,7 @@
       <p:grpSpPr/>
       <p:pic>
         <p:nvPicPr>
-          <p:cNvPr id="2" name="Picture 1" descr="slide-06.png"/>
+          <p:cNvPr id="2" name="Picture 1" descr="slide-07.png"/>
           <p:cNvPicPr>
             <a:picLocks noChangeAspect="1"/>
           </p:cNvPicPr>
@@ -3276,7 +3276,7 @@
       <p:grpSpPr/>
       <p:pic>
         <p:nvPicPr>
-          <p:cNvPr id="2" name="Picture 1" descr="slide-06.png"/>
+          <p:cNvPr id="2" name="Picture 1" descr="slide-07.png"/>
           <p:cNvPicPr>
             <a:picLocks noChangeAspect="1"/>
           </p:cNvPicPr>
@@ -3318,7 +3318,7 @@
       <p:grpSpPr/>
       <p:pic>
         <p:nvPicPr>
-          <p:cNvPr id="2" name="Picture 1" descr="slide-06.png"/>
+          <p:cNvPr id="2" name="Picture 1" descr="slide-07.png"/>
           <p:cNvPicPr>
             <a:picLocks noChangeAspect="1"/>
           </p:cNvPicPr>
@@ -3360,7 +3360,7 @@
       <p:grpSpPr/>
       <p:pic>
         <p:nvPicPr>
-          <p:cNvPr id="2" name="Picture 1" descr="slide-06.png"/>
+          <p:cNvPr id="2" name="Picture 1" descr="slide-07.png"/>
           <p:cNvPicPr>
             <a:picLocks noChangeAspect="1"/>
           </p:cNvPicPr>
@@ -3402,7 +3402,7 @@
       <p:grpSpPr/>
       <p:pic>
         <p:nvPicPr>
-          <p:cNvPr id="2" name="Picture 1" descr="slide-06.png"/>
+          <p:cNvPr id="2" name="Picture 1" descr="slide-07.png"/>
           <p:cNvPicPr>
             <a:picLocks noChangeAspect="1"/>
           </p:cNvPicPr>
@@ -3444,7 +3444,7 @@
       <p:grpSpPr/>
       <p:pic>
         <p:nvPicPr>
-          <p:cNvPr id="2" name="Picture 1" descr="slide-06.png"/>
+          <p:cNvPr id="2" name="Picture 1" descr="slide-07.png"/>
           <p:cNvPicPr>
             <a:picLocks noChangeAspect="1"/>
           </p:cNvPicPr>
@@ -3486,7 +3486,7 @@
       <p:grpSpPr/>
       <p:pic>
         <p:nvPicPr>
-          <p:cNvPr id="2" name="Picture 1" descr="slide-06.png"/>
+          <p:cNvPr id="2" name="Picture 1" descr="slide-07.png"/>
           <p:cNvPicPr>
             <a:picLocks noChangeAspect="1"/>
           </p:cNvPicPr>
@@ -3528,7 +3528,7 @@
       <p:grpSpPr/>
       <p:pic>
         <p:nvPicPr>
-          <p:cNvPr id="2" name="Picture 1" descr="slide-06.png"/>
+          <p:cNvPr id="2" name="Picture 1" descr="slide-07.png"/>
           <p:cNvPicPr>
             <a:picLocks noChangeAspect="1"/>
           </p:cNvPicPr>
@@ -3780,7 +3780,7 @@
       <p:grpSpPr/>
       <p:pic>
         <p:nvPicPr>
-          <p:cNvPr id="2" name="Picture 1" descr="slide-06.png"/>
+          <p:cNvPr id="2" name="Picture 1" descr="slide-07.png"/>
           <p:cNvPicPr>
             <a:picLocks noChangeAspect="1"/>
           </p:cNvPicPr>
@@ -3822,7 +3822,7 @@
       <p:grpSpPr/>
       <p:pic>
         <p:nvPicPr>
-          <p:cNvPr id="2" name="Picture 1" descr="slide-06.png"/>
+          <p:cNvPr id="2" name="Picture 1" descr="slide-07.png"/>
           <p:cNvPicPr>
             <a:picLocks noChangeAspect="1"/>
           </p:cNvPicPr>
@@ -3864,7 +3864,7 @@
       <p:grpSpPr/>
       <p:pic>
         <p:nvPicPr>
-          <p:cNvPr id="2" name="Picture 1" descr="slide-06.png"/>
+          <p:cNvPr id="2" name="Picture 1" descr="slide-07.png"/>
           <p:cNvPicPr>
             <a:picLocks noChangeAspect="1"/>
           </p:cNvPicPr>

</xml_diff>

<commit_message>
Clear round 2 deck footer from navigation hint
Co-Authored-By: Alexandre Cela <alexandrecelap@gmail.com>
</commit_message>
<xml_diff>
--- a/outputs/prototypes/asset-nova-round2-deck.pptx
+++ b/outputs/prototypes/asset-nova-round2-deck.pptx
@@ -3150,7 +3150,7 @@
       <p:grpSpPr/>
       <p:pic>
         <p:nvPicPr>
-          <p:cNvPr id="2" name="Picture 1" descr="slide-07.png"/>
+          <p:cNvPr id="2" name="Picture 1" descr="slide-06.png"/>
           <p:cNvPicPr>
             <a:picLocks noChangeAspect="1"/>
           </p:cNvPicPr>
@@ -3192,7 +3192,7 @@
       <p:grpSpPr/>
       <p:pic>
         <p:nvPicPr>
-          <p:cNvPr id="2" name="Picture 1" descr="slide-07.png"/>
+          <p:cNvPr id="2" name="Picture 1" descr="slide-06.png"/>
           <p:cNvPicPr>
             <a:picLocks noChangeAspect="1"/>
           </p:cNvPicPr>
@@ -3234,7 +3234,7 @@
       <p:grpSpPr/>
       <p:pic>
         <p:nvPicPr>
-          <p:cNvPr id="2" name="Picture 1" descr="slide-07.png"/>
+          <p:cNvPr id="2" name="Picture 1" descr="slide-06.png"/>
           <p:cNvPicPr>
             <a:picLocks noChangeAspect="1"/>
           </p:cNvPicPr>
@@ -3276,7 +3276,7 @@
       <p:grpSpPr/>
       <p:pic>
         <p:nvPicPr>
-          <p:cNvPr id="2" name="Picture 1" descr="slide-07.png"/>
+          <p:cNvPr id="2" name="Picture 1" descr="slide-06.png"/>
           <p:cNvPicPr>
             <a:picLocks noChangeAspect="1"/>
           </p:cNvPicPr>
@@ -3318,7 +3318,7 @@
       <p:grpSpPr/>
       <p:pic>
         <p:nvPicPr>
-          <p:cNvPr id="2" name="Picture 1" descr="slide-07.png"/>
+          <p:cNvPr id="2" name="Picture 1" descr="slide-06.png"/>
           <p:cNvPicPr>
             <a:picLocks noChangeAspect="1"/>
           </p:cNvPicPr>
@@ -3360,7 +3360,7 @@
       <p:grpSpPr/>
       <p:pic>
         <p:nvPicPr>
-          <p:cNvPr id="2" name="Picture 1" descr="slide-07.png"/>
+          <p:cNvPr id="2" name="Picture 1" descr="slide-06.png"/>
           <p:cNvPicPr>
             <a:picLocks noChangeAspect="1"/>
           </p:cNvPicPr>
@@ -3402,7 +3402,7 @@
       <p:grpSpPr/>
       <p:pic>
         <p:nvPicPr>
-          <p:cNvPr id="2" name="Picture 1" descr="slide-07.png"/>
+          <p:cNvPr id="2" name="Picture 1" descr="slide-06.png"/>
           <p:cNvPicPr>
             <a:picLocks noChangeAspect="1"/>
           </p:cNvPicPr>
@@ -3444,7 +3444,7 @@
       <p:grpSpPr/>
       <p:pic>
         <p:nvPicPr>
-          <p:cNvPr id="2" name="Picture 1" descr="slide-07.png"/>
+          <p:cNvPr id="2" name="Picture 1" descr="slide-06.png"/>
           <p:cNvPicPr>
             <a:picLocks noChangeAspect="1"/>
           </p:cNvPicPr>
@@ -3486,7 +3486,7 @@
       <p:grpSpPr/>
       <p:pic>
         <p:nvPicPr>
-          <p:cNvPr id="2" name="Picture 1" descr="slide-07.png"/>
+          <p:cNvPr id="2" name="Picture 1" descr="slide-06.png"/>
           <p:cNvPicPr>
             <a:picLocks noChangeAspect="1"/>
           </p:cNvPicPr>
@@ -3528,7 +3528,7 @@
       <p:grpSpPr/>
       <p:pic>
         <p:nvPicPr>
-          <p:cNvPr id="2" name="Picture 1" descr="slide-07.png"/>
+          <p:cNvPr id="2" name="Picture 1" descr="slide-06.png"/>
           <p:cNvPicPr>
             <a:picLocks noChangeAspect="1"/>
           </p:cNvPicPr>
@@ -3780,7 +3780,7 @@
       <p:grpSpPr/>
       <p:pic>
         <p:nvPicPr>
-          <p:cNvPr id="2" name="Picture 1" descr="slide-07.png"/>
+          <p:cNvPr id="2" name="Picture 1" descr="slide-06.png"/>
           <p:cNvPicPr>
             <a:picLocks noChangeAspect="1"/>
           </p:cNvPicPr>
@@ -3822,7 +3822,7 @@
       <p:grpSpPr/>
       <p:pic>
         <p:nvPicPr>
-          <p:cNvPr id="2" name="Picture 1" descr="slide-07.png"/>
+          <p:cNvPr id="2" name="Picture 1" descr="slide-06.png"/>
           <p:cNvPicPr>
             <a:picLocks noChangeAspect="1"/>
           </p:cNvPicPr>
@@ -3864,7 +3864,7 @@
       <p:grpSpPr/>
       <p:pic>
         <p:nvPicPr>
-          <p:cNvPr id="2" name="Picture 1" descr="slide-07.png"/>
+          <p:cNvPr id="2" name="Picture 1" descr="slide-06.png"/>
           <p:cNvPicPr>
             <a:picLocks noChangeAspect="1"/>
           </p:cNvPicPr>

</xml_diff>

<commit_message>
Add agentic scenarios and evaluation gates
Co-Authored-By: Alexandre Cela <alexandrecelap@gmail.com>
</commit_message>
<xml_diff>
--- a/outputs/prototypes/asset-nova-round2-deck.pptx
+++ b/outputs/prototypes/asset-nova-round2-deck.pptx
@@ -24,6 +24,12 @@
     <p:sldId id="272" r:id="rId23"/>
     <p:sldId id="273" r:id="rId24"/>
     <p:sldId id="274" r:id="rId25"/>
+    <p:sldId id="275" r:id="rId26"/>
+    <p:sldId id="276" r:id="rId27"/>
+    <p:sldId id="277" r:id="rId28"/>
+    <p:sldId id="278" r:id="rId29"/>
+    <p:sldId id="279" r:id="rId30"/>
+    <p:sldId id="280" r:id="rId31"/>
   </p:sldIdLst>
   <p:sldSz cx="12191999" cy="6858000" type="screen4x3"/>
   <p:notesSz cx="6858000" cy="9144000"/>
@@ -3150,7 +3156,7 @@
       <p:grpSpPr/>
       <p:pic>
         <p:nvPicPr>
-          <p:cNvPr id="2" name="Picture 1" descr="slide-06.png"/>
+          <p:cNvPr id="2" name="Picture 1" descr="slide-07.png"/>
           <p:cNvPicPr>
             <a:picLocks noChangeAspect="1"/>
           </p:cNvPicPr>
@@ -3192,7 +3198,7 @@
       <p:grpSpPr/>
       <p:pic>
         <p:nvPicPr>
-          <p:cNvPr id="2" name="Picture 1" descr="slide-06.png"/>
+          <p:cNvPr id="2" name="Picture 1" descr="slide-07.png"/>
           <p:cNvPicPr>
             <a:picLocks noChangeAspect="1"/>
           </p:cNvPicPr>
@@ -3234,7 +3240,7 @@
       <p:grpSpPr/>
       <p:pic>
         <p:nvPicPr>
-          <p:cNvPr id="2" name="Picture 1" descr="slide-06.png"/>
+          <p:cNvPr id="2" name="Picture 1" descr="slide-07.png"/>
           <p:cNvPicPr>
             <a:picLocks noChangeAspect="1"/>
           </p:cNvPicPr>
@@ -3276,7 +3282,7 @@
       <p:grpSpPr/>
       <p:pic>
         <p:nvPicPr>
-          <p:cNvPr id="2" name="Picture 1" descr="slide-06.png"/>
+          <p:cNvPr id="2" name="Picture 1" descr="slide-07.png"/>
           <p:cNvPicPr>
             <a:picLocks noChangeAspect="1"/>
           </p:cNvPicPr>
@@ -3318,7 +3324,7 @@
       <p:grpSpPr/>
       <p:pic>
         <p:nvPicPr>
-          <p:cNvPr id="2" name="Picture 1" descr="slide-06.png"/>
+          <p:cNvPr id="2" name="Picture 1" descr="slide-07.png"/>
           <p:cNvPicPr>
             <a:picLocks noChangeAspect="1"/>
           </p:cNvPicPr>
@@ -3360,7 +3366,7 @@
       <p:grpSpPr/>
       <p:pic>
         <p:nvPicPr>
-          <p:cNvPr id="2" name="Picture 1" descr="slide-06.png"/>
+          <p:cNvPr id="2" name="Picture 1" descr="slide-07.png"/>
           <p:cNvPicPr>
             <a:picLocks noChangeAspect="1"/>
           </p:cNvPicPr>
@@ -3402,7 +3408,7 @@
       <p:grpSpPr/>
       <p:pic>
         <p:nvPicPr>
-          <p:cNvPr id="2" name="Picture 1" descr="slide-06.png"/>
+          <p:cNvPr id="2" name="Picture 1" descr="slide-07.png"/>
           <p:cNvPicPr>
             <a:picLocks noChangeAspect="1"/>
           </p:cNvPicPr>
@@ -3444,7 +3450,7 @@
       <p:grpSpPr/>
       <p:pic>
         <p:nvPicPr>
-          <p:cNvPr id="2" name="Picture 1" descr="slide-06.png"/>
+          <p:cNvPr id="2" name="Picture 1" descr="slide-07.png"/>
           <p:cNvPicPr>
             <a:picLocks noChangeAspect="1"/>
           </p:cNvPicPr>
@@ -3486,7 +3492,7 @@
       <p:grpSpPr/>
       <p:pic>
         <p:nvPicPr>
-          <p:cNvPr id="2" name="Picture 1" descr="slide-06.png"/>
+          <p:cNvPr id="2" name="Picture 1" descr="slide-07.png"/>
           <p:cNvPicPr>
             <a:picLocks noChangeAspect="1"/>
           </p:cNvPicPr>
@@ -3528,7 +3534,7 @@
       <p:grpSpPr/>
       <p:pic>
         <p:nvPicPr>
-          <p:cNvPr id="2" name="Picture 1" descr="slide-06.png"/>
+          <p:cNvPr id="2" name="Picture 1" descr="slide-07.png"/>
           <p:cNvPicPr>
             <a:picLocks noChangeAspect="1"/>
           </p:cNvPicPr>
@@ -3600,6 +3606,258 @@
 </p:sld>
 </file>
 
+<file path=ppt/slides/slide20.xml><?xml version="1.0" encoding="utf-8"?>
+<p:sld xmlns:a="http://schemas.openxmlformats.org/drawingml/2006/main" xmlns:p="http://schemas.openxmlformats.org/presentationml/2006/main" xmlns:r="http://schemas.openxmlformats.org/officeDocument/2006/relationships">
+  <p:cSld>
+    <p:spTree>
+      <p:nvGrpSpPr>
+        <p:cNvPr id="1" name=""/>
+        <p:cNvGrpSpPr/>
+        <p:nvPr/>
+      </p:nvGrpSpPr>
+      <p:grpSpPr/>
+      <p:pic>
+        <p:nvPicPr>
+          <p:cNvPr id="2" name="Picture 1" descr="slide-07.png"/>
+          <p:cNvPicPr>
+            <a:picLocks noChangeAspect="1"/>
+          </p:cNvPicPr>
+          <p:nvPr/>
+        </p:nvPicPr>
+        <p:blipFill>
+          <a:blip r:embed="rId2"/>
+          <a:stretch>
+            <a:fillRect/>
+          </a:stretch>
+        </p:blipFill>
+        <p:spPr>
+          <a:xfrm>
+            <a:off x="0" y="0"/>
+            <a:ext cx="12191999" cy="6858000"/>
+          </a:xfrm>
+          <a:prstGeom prst="rect">
+            <a:avLst/>
+          </a:prstGeom>
+        </p:spPr>
+      </p:pic>
+    </p:spTree>
+  </p:cSld>
+  <p:clrMapOvr>
+    <a:masterClrMapping/>
+  </p:clrMapOvr>
+</p:sld>
+</file>
+
+<file path=ppt/slides/slide21.xml><?xml version="1.0" encoding="utf-8"?>
+<p:sld xmlns:a="http://schemas.openxmlformats.org/drawingml/2006/main" xmlns:p="http://schemas.openxmlformats.org/presentationml/2006/main" xmlns:r="http://schemas.openxmlformats.org/officeDocument/2006/relationships">
+  <p:cSld>
+    <p:spTree>
+      <p:nvGrpSpPr>
+        <p:cNvPr id="1" name=""/>
+        <p:cNvGrpSpPr/>
+        <p:nvPr/>
+      </p:nvGrpSpPr>
+      <p:grpSpPr/>
+      <p:pic>
+        <p:nvPicPr>
+          <p:cNvPr id="2" name="Picture 1" descr="slide-07.png"/>
+          <p:cNvPicPr>
+            <a:picLocks noChangeAspect="1"/>
+          </p:cNvPicPr>
+          <p:nvPr/>
+        </p:nvPicPr>
+        <p:blipFill>
+          <a:blip r:embed="rId2"/>
+          <a:stretch>
+            <a:fillRect/>
+          </a:stretch>
+        </p:blipFill>
+        <p:spPr>
+          <a:xfrm>
+            <a:off x="0" y="0"/>
+            <a:ext cx="12191999" cy="6858000"/>
+          </a:xfrm>
+          <a:prstGeom prst="rect">
+            <a:avLst/>
+          </a:prstGeom>
+        </p:spPr>
+      </p:pic>
+    </p:spTree>
+  </p:cSld>
+  <p:clrMapOvr>
+    <a:masterClrMapping/>
+  </p:clrMapOvr>
+</p:sld>
+</file>
+
+<file path=ppt/slides/slide22.xml><?xml version="1.0" encoding="utf-8"?>
+<p:sld xmlns:a="http://schemas.openxmlformats.org/drawingml/2006/main" xmlns:p="http://schemas.openxmlformats.org/presentationml/2006/main" xmlns:r="http://schemas.openxmlformats.org/officeDocument/2006/relationships">
+  <p:cSld>
+    <p:spTree>
+      <p:nvGrpSpPr>
+        <p:cNvPr id="1" name=""/>
+        <p:cNvGrpSpPr/>
+        <p:nvPr/>
+      </p:nvGrpSpPr>
+      <p:grpSpPr/>
+      <p:pic>
+        <p:nvPicPr>
+          <p:cNvPr id="2" name="Picture 1" descr="slide-07.png"/>
+          <p:cNvPicPr>
+            <a:picLocks noChangeAspect="1"/>
+          </p:cNvPicPr>
+          <p:nvPr/>
+        </p:nvPicPr>
+        <p:blipFill>
+          <a:blip r:embed="rId2"/>
+          <a:stretch>
+            <a:fillRect/>
+          </a:stretch>
+        </p:blipFill>
+        <p:spPr>
+          <a:xfrm>
+            <a:off x="0" y="0"/>
+            <a:ext cx="12191999" cy="6858000"/>
+          </a:xfrm>
+          <a:prstGeom prst="rect">
+            <a:avLst/>
+          </a:prstGeom>
+        </p:spPr>
+      </p:pic>
+    </p:spTree>
+  </p:cSld>
+  <p:clrMapOvr>
+    <a:masterClrMapping/>
+  </p:clrMapOvr>
+</p:sld>
+</file>
+
+<file path=ppt/slides/slide23.xml><?xml version="1.0" encoding="utf-8"?>
+<p:sld xmlns:a="http://schemas.openxmlformats.org/drawingml/2006/main" xmlns:p="http://schemas.openxmlformats.org/presentationml/2006/main" xmlns:r="http://schemas.openxmlformats.org/officeDocument/2006/relationships">
+  <p:cSld>
+    <p:spTree>
+      <p:nvGrpSpPr>
+        <p:cNvPr id="1" name=""/>
+        <p:cNvGrpSpPr/>
+        <p:nvPr/>
+      </p:nvGrpSpPr>
+      <p:grpSpPr/>
+      <p:pic>
+        <p:nvPicPr>
+          <p:cNvPr id="2" name="Picture 1" descr="slide-07.png"/>
+          <p:cNvPicPr>
+            <a:picLocks noChangeAspect="1"/>
+          </p:cNvPicPr>
+          <p:nvPr/>
+        </p:nvPicPr>
+        <p:blipFill>
+          <a:blip r:embed="rId2"/>
+          <a:stretch>
+            <a:fillRect/>
+          </a:stretch>
+        </p:blipFill>
+        <p:spPr>
+          <a:xfrm>
+            <a:off x="0" y="0"/>
+            <a:ext cx="12191999" cy="6858000"/>
+          </a:xfrm>
+          <a:prstGeom prst="rect">
+            <a:avLst/>
+          </a:prstGeom>
+        </p:spPr>
+      </p:pic>
+    </p:spTree>
+  </p:cSld>
+  <p:clrMapOvr>
+    <a:masterClrMapping/>
+  </p:clrMapOvr>
+</p:sld>
+</file>
+
+<file path=ppt/slides/slide24.xml><?xml version="1.0" encoding="utf-8"?>
+<p:sld xmlns:a="http://schemas.openxmlformats.org/drawingml/2006/main" xmlns:p="http://schemas.openxmlformats.org/presentationml/2006/main" xmlns:r="http://schemas.openxmlformats.org/officeDocument/2006/relationships">
+  <p:cSld>
+    <p:spTree>
+      <p:nvGrpSpPr>
+        <p:cNvPr id="1" name=""/>
+        <p:cNvGrpSpPr/>
+        <p:nvPr/>
+      </p:nvGrpSpPr>
+      <p:grpSpPr/>
+      <p:pic>
+        <p:nvPicPr>
+          <p:cNvPr id="2" name="Picture 1" descr="slide-07.png"/>
+          <p:cNvPicPr>
+            <a:picLocks noChangeAspect="1"/>
+          </p:cNvPicPr>
+          <p:nvPr/>
+        </p:nvPicPr>
+        <p:blipFill>
+          <a:blip r:embed="rId2"/>
+          <a:stretch>
+            <a:fillRect/>
+          </a:stretch>
+        </p:blipFill>
+        <p:spPr>
+          <a:xfrm>
+            <a:off x="0" y="0"/>
+            <a:ext cx="12191999" cy="6858000"/>
+          </a:xfrm>
+          <a:prstGeom prst="rect">
+            <a:avLst/>
+          </a:prstGeom>
+        </p:spPr>
+      </p:pic>
+    </p:spTree>
+  </p:cSld>
+  <p:clrMapOvr>
+    <a:masterClrMapping/>
+  </p:clrMapOvr>
+</p:sld>
+</file>
+
+<file path=ppt/slides/slide25.xml><?xml version="1.0" encoding="utf-8"?>
+<p:sld xmlns:a="http://schemas.openxmlformats.org/drawingml/2006/main" xmlns:p="http://schemas.openxmlformats.org/presentationml/2006/main" xmlns:r="http://schemas.openxmlformats.org/officeDocument/2006/relationships">
+  <p:cSld>
+    <p:spTree>
+      <p:nvGrpSpPr>
+        <p:cNvPr id="1" name=""/>
+        <p:cNvGrpSpPr/>
+        <p:nvPr/>
+      </p:nvGrpSpPr>
+      <p:grpSpPr/>
+      <p:pic>
+        <p:nvPicPr>
+          <p:cNvPr id="2" name="Picture 1" descr="slide-07.png"/>
+          <p:cNvPicPr>
+            <a:picLocks noChangeAspect="1"/>
+          </p:cNvPicPr>
+          <p:nvPr/>
+        </p:nvPicPr>
+        <p:blipFill>
+          <a:blip r:embed="rId2"/>
+          <a:stretch>
+            <a:fillRect/>
+          </a:stretch>
+        </p:blipFill>
+        <p:spPr>
+          <a:xfrm>
+            <a:off x="0" y="0"/>
+            <a:ext cx="12191999" cy="6858000"/>
+          </a:xfrm>
+          <a:prstGeom prst="rect">
+            <a:avLst/>
+          </a:prstGeom>
+        </p:spPr>
+      </p:pic>
+    </p:spTree>
+  </p:cSld>
+  <p:clrMapOvr>
+    <a:masterClrMapping/>
+  </p:clrMapOvr>
+</p:sld>
+</file>
+
 <file path=ppt/slides/slide3.xml><?xml version="1.0" encoding="utf-8"?>
 <p:sld xmlns:a="http://schemas.openxmlformats.org/drawingml/2006/main" xmlns:p="http://schemas.openxmlformats.org/presentationml/2006/main" xmlns:r="http://schemas.openxmlformats.org/officeDocument/2006/relationships">
   <p:cSld>
@@ -3780,7 +4038,7 @@
       <p:grpSpPr/>
       <p:pic>
         <p:nvPicPr>
-          <p:cNvPr id="2" name="Picture 1" descr="slide-06.png"/>
+          <p:cNvPr id="2" name="Picture 1" descr="slide-07.png"/>
           <p:cNvPicPr>
             <a:picLocks noChangeAspect="1"/>
           </p:cNvPicPr>
@@ -3822,7 +4080,7 @@
       <p:grpSpPr/>
       <p:pic>
         <p:nvPicPr>
-          <p:cNvPr id="2" name="Picture 1" descr="slide-06.png"/>
+          <p:cNvPr id="2" name="Picture 1" descr="slide-07.png"/>
           <p:cNvPicPr>
             <a:picLocks noChangeAspect="1"/>
           </p:cNvPicPr>
@@ -3864,7 +4122,7 @@
       <p:grpSpPr/>
       <p:pic>
         <p:nvPicPr>
-          <p:cNvPr id="2" name="Picture 1" descr="slide-06.png"/>
+          <p:cNvPr id="2" name="Picture 1" descr="slide-07.png"/>
           <p:cNvPicPr>
             <a:picLocks noChangeAspect="1"/>
           </p:cNvPicPr>

</xml_diff>

<commit_message>
Add Product 1 delivery plan slide
Co-Authored-By: Alexandre Cela <alexandrecelap@gmail.com>
</commit_message>
<xml_diff>
--- a/outputs/prototypes/asset-nova-round2-deck.pptx
+++ b/outputs/prototypes/asset-nova-round2-deck.pptx
@@ -30,6 +30,7 @@
     <p:sldId id="278" r:id="rId29"/>
     <p:sldId id="279" r:id="rId30"/>
     <p:sldId id="280" r:id="rId31"/>
+    <p:sldId id="281" r:id="rId32"/>
   </p:sldIdLst>
   <p:sldSz cx="12191999" cy="6858000" type="screen4x3"/>
   <p:notesSz cx="6858000" cy="9144000"/>
@@ -3156,7 +3157,7 @@
       <p:grpSpPr/>
       <p:pic>
         <p:nvPicPr>
-          <p:cNvPr id="2" name="Picture 1" descr="slide-07.png"/>
+          <p:cNvPr id="2" name="Picture 1" descr="slide-06.png"/>
           <p:cNvPicPr>
             <a:picLocks noChangeAspect="1"/>
           </p:cNvPicPr>
@@ -3198,7 +3199,7 @@
       <p:grpSpPr/>
       <p:pic>
         <p:nvPicPr>
-          <p:cNvPr id="2" name="Picture 1" descr="slide-07.png"/>
+          <p:cNvPr id="2" name="Picture 1" descr="slide-06.png"/>
           <p:cNvPicPr>
             <a:picLocks noChangeAspect="1"/>
           </p:cNvPicPr>
@@ -3240,7 +3241,7 @@
       <p:grpSpPr/>
       <p:pic>
         <p:nvPicPr>
-          <p:cNvPr id="2" name="Picture 1" descr="slide-07.png"/>
+          <p:cNvPr id="2" name="Picture 1" descr="slide-06.png"/>
           <p:cNvPicPr>
             <a:picLocks noChangeAspect="1"/>
           </p:cNvPicPr>
@@ -3282,7 +3283,7 @@
       <p:grpSpPr/>
       <p:pic>
         <p:nvPicPr>
-          <p:cNvPr id="2" name="Picture 1" descr="slide-07.png"/>
+          <p:cNvPr id="2" name="Picture 1" descr="slide-06.png"/>
           <p:cNvPicPr>
             <a:picLocks noChangeAspect="1"/>
           </p:cNvPicPr>
@@ -3324,7 +3325,7 @@
       <p:grpSpPr/>
       <p:pic>
         <p:nvPicPr>
-          <p:cNvPr id="2" name="Picture 1" descr="slide-07.png"/>
+          <p:cNvPr id="2" name="Picture 1" descr="slide-06.png"/>
           <p:cNvPicPr>
             <a:picLocks noChangeAspect="1"/>
           </p:cNvPicPr>
@@ -3366,7 +3367,7 @@
       <p:grpSpPr/>
       <p:pic>
         <p:nvPicPr>
-          <p:cNvPr id="2" name="Picture 1" descr="slide-07.png"/>
+          <p:cNvPr id="2" name="Picture 1" descr="slide-06.png"/>
           <p:cNvPicPr>
             <a:picLocks noChangeAspect="1"/>
           </p:cNvPicPr>
@@ -3408,7 +3409,7 @@
       <p:grpSpPr/>
       <p:pic>
         <p:nvPicPr>
-          <p:cNvPr id="2" name="Picture 1" descr="slide-07.png"/>
+          <p:cNvPr id="2" name="Picture 1" descr="slide-06.png"/>
           <p:cNvPicPr>
             <a:picLocks noChangeAspect="1"/>
           </p:cNvPicPr>
@@ -3450,7 +3451,7 @@
       <p:grpSpPr/>
       <p:pic>
         <p:nvPicPr>
-          <p:cNvPr id="2" name="Picture 1" descr="slide-07.png"/>
+          <p:cNvPr id="2" name="Picture 1" descr="slide-06.png"/>
           <p:cNvPicPr>
             <a:picLocks noChangeAspect="1"/>
           </p:cNvPicPr>
@@ -3492,7 +3493,7 @@
       <p:grpSpPr/>
       <p:pic>
         <p:nvPicPr>
-          <p:cNvPr id="2" name="Picture 1" descr="slide-07.png"/>
+          <p:cNvPr id="2" name="Picture 1" descr="slide-06.png"/>
           <p:cNvPicPr>
             <a:picLocks noChangeAspect="1"/>
           </p:cNvPicPr>
@@ -3534,7 +3535,7 @@
       <p:grpSpPr/>
       <p:pic>
         <p:nvPicPr>
-          <p:cNvPr id="2" name="Picture 1" descr="slide-07.png"/>
+          <p:cNvPr id="2" name="Picture 1" descr="slide-06.png"/>
           <p:cNvPicPr>
             <a:picLocks noChangeAspect="1"/>
           </p:cNvPicPr>
@@ -3618,7 +3619,7 @@
       <p:grpSpPr/>
       <p:pic>
         <p:nvPicPr>
-          <p:cNvPr id="2" name="Picture 1" descr="slide-07.png"/>
+          <p:cNvPr id="2" name="Picture 1" descr="slide-06.png"/>
           <p:cNvPicPr>
             <a:picLocks noChangeAspect="1"/>
           </p:cNvPicPr>
@@ -3660,7 +3661,7 @@
       <p:grpSpPr/>
       <p:pic>
         <p:nvPicPr>
-          <p:cNvPr id="2" name="Picture 1" descr="slide-07.png"/>
+          <p:cNvPr id="2" name="Picture 1" descr="slide-06.png"/>
           <p:cNvPicPr>
             <a:picLocks noChangeAspect="1"/>
           </p:cNvPicPr>
@@ -3702,7 +3703,7 @@
       <p:grpSpPr/>
       <p:pic>
         <p:nvPicPr>
-          <p:cNvPr id="2" name="Picture 1" descr="slide-07.png"/>
+          <p:cNvPr id="2" name="Picture 1" descr="slide-06.png"/>
           <p:cNvPicPr>
             <a:picLocks noChangeAspect="1"/>
           </p:cNvPicPr>
@@ -3744,7 +3745,7 @@
       <p:grpSpPr/>
       <p:pic>
         <p:nvPicPr>
-          <p:cNvPr id="2" name="Picture 1" descr="slide-07.png"/>
+          <p:cNvPr id="2" name="Picture 1" descr="slide-06.png"/>
           <p:cNvPicPr>
             <a:picLocks noChangeAspect="1"/>
           </p:cNvPicPr>
@@ -3786,7 +3787,7 @@
       <p:grpSpPr/>
       <p:pic>
         <p:nvPicPr>
-          <p:cNvPr id="2" name="Picture 1" descr="slide-07.png"/>
+          <p:cNvPr id="2" name="Picture 1" descr="slide-06.png"/>
           <p:cNvPicPr>
             <a:picLocks noChangeAspect="1"/>
           </p:cNvPicPr>
@@ -3828,7 +3829,49 @@
       <p:grpSpPr/>
       <p:pic>
         <p:nvPicPr>
-          <p:cNvPr id="2" name="Picture 1" descr="slide-07.png"/>
+          <p:cNvPr id="2" name="Picture 1" descr="slide-06.png"/>
+          <p:cNvPicPr>
+            <a:picLocks noChangeAspect="1"/>
+          </p:cNvPicPr>
+          <p:nvPr/>
+        </p:nvPicPr>
+        <p:blipFill>
+          <a:blip r:embed="rId2"/>
+          <a:stretch>
+            <a:fillRect/>
+          </a:stretch>
+        </p:blipFill>
+        <p:spPr>
+          <a:xfrm>
+            <a:off x="0" y="0"/>
+            <a:ext cx="12191999" cy="6858000"/>
+          </a:xfrm>
+          <a:prstGeom prst="rect">
+            <a:avLst/>
+          </a:prstGeom>
+        </p:spPr>
+      </p:pic>
+    </p:spTree>
+  </p:cSld>
+  <p:clrMapOvr>
+    <a:masterClrMapping/>
+  </p:clrMapOvr>
+</p:sld>
+</file>
+
+<file path=ppt/slides/slide26.xml><?xml version="1.0" encoding="utf-8"?>
+<p:sld xmlns:a="http://schemas.openxmlformats.org/drawingml/2006/main" xmlns:p="http://schemas.openxmlformats.org/presentationml/2006/main" xmlns:r="http://schemas.openxmlformats.org/officeDocument/2006/relationships">
+  <p:cSld>
+    <p:spTree>
+      <p:nvGrpSpPr>
+        <p:cNvPr id="1" name=""/>
+        <p:cNvGrpSpPr/>
+        <p:nvPr/>
+      </p:nvGrpSpPr>
+      <p:grpSpPr/>
+      <p:pic>
+        <p:nvPicPr>
+          <p:cNvPr id="2" name="Picture 1" descr="slide-06.png"/>
           <p:cNvPicPr>
             <a:picLocks noChangeAspect="1"/>
           </p:cNvPicPr>
@@ -4038,7 +4081,7 @@
       <p:grpSpPr/>
       <p:pic>
         <p:nvPicPr>
-          <p:cNvPr id="2" name="Picture 1" descr="slide-07.png"/>
+          <p:cNvPr id="2" name="Picture 1" descr="slide-06.png"/>
           <p:cNvPicPr>
             <a:picLocks noChangeAspect="1"/>
           </p:cNvPicPr>
@@ -4080,7 +4123,7 @@
       <p:grpSpPr/>
       <p:pic>
         <p:nvPicPr>
-          <p:cNvPr id="2" name="Picture 1" descr="slide-07.png"/>
+          <p:cNvPr id="2" name="Picture 1" descr="slide-06.png"/>
           <p:cNvPicPr>
             <a:picLocks noChangeAspect="1"/>
           </p:cNvPicPr>
@@ -4122,7 +4165,7 @@
       <p:grpSpPr/>
       <p:pic>
         <p:nvPicPr>
-          <p:cNvPr id="2" name="Picture 1" descr="slide-07.png"/>
+          <p:cNvPr id="2" name="Picture 1" descr="slide-06.png"/>
           <p:cNvPicPr>
             <a:picLocks noChangeAspect="1"/>
           </p:cNvPicPr>

</xml_diff>